<commit_message>
Reframe Cerno presentation as a product reveal
</commit_message>
<xml_diff>
--- a/presentation/output/Cerno-Hackathon-Presentation.pptx
+++ b/presentation/output/Cerno-Hackathon-Presentation.pptx
@@ -3331,23 +3331,23 @@
               </a:spcAft>
             </a:pPr>
             <a:r>
-              <a:rPr sz="3300" b="1" i="0">
+              <a:rPr sz="3600" b="1" i="0">
                 <a:solidFill>
                   <a:srgbClr val="FFFFFF"/>
                 </a:solidFill>
                 <a:latin typeface="Georgia"/>
               </a:rPr>
-              <a:t>The judgment layer between</a:t>
+              <a:t>Your personal research desk.</a:t>
             </a:r>
             <a:br/>
             <a:r>
-              <a:rPr sz="3300" b="1" i="0">
+              <a:rPr sz="3600" b="1" i="0">
                 <a:solidFill>
                   <a:srgbClr val="FFFFFF"/>
                 </a:solidFill>
                 <a:latin typeface="Georgia"/>
               </a:rPr>
-              <a:t>the internet and your attention.</a:t>
+              <a:t>Staffed by agents.</a:t>
             </a:r>
           </a:p>
         </p:txBody>
@@ -3392,7 +3392,7 @@
                 </a:solidFill>
                 <a:latin typeface="Avenir Next"/>
               </a:rPr>
-              <a:t>A personal research-and-briefing desk, run by agents.</a:t>
+              <a:t>One mission in. One finite, cited briefing out.</a:t>
             </a:r>
           </a:p>
         </p:txBody>
@@ -9865,7 +9865,7 @@
         <p:spPr>
           <a:xfrm>
             <a:off x="658368" y="850392"/>
-            <a:ext cx="3108960" cy="228600"/>
+            <a:ext cx="3474720" cy="228600"/>
           </a:xfrm>
           <a:prstGeom prst="rect">
             <a:avLst/>
@@ -9896,7 +9896,7 @@
                 </a:solidFill>
                 <a:latin typeface="Menlo"/>
               </a:rPr>
-              <a:t>VERIFIED LIVE RUN · 12 JUL 2026</a:t>
+              <a:t>VERIFIED PRODUCTION RUNS · 12 JUL 2026</a:t>
             </a:r>
           </a:p>
         </p:txBody>
@@ -9941,7 +9941,7 @@
                 </a:solidFill>
                 <a:latin typeface="Georgia"/>
               </a:rPr>
-              <a:t>One run. Every claim inspectable.</a:t>
+              <a:t>Two missions. Every claim inspectable.</a:t>
             </a:r>
           </a:p>
         </p:txBody>
@@ -10074,7 +10074,7 @@
                 </a:solidFill>
                 <a:latin typeface="Avenir Next"/>
               </a:rPr>
-              <a:t>102.6s</a:t>
+              <a:t>2</a:t>
             </a:r>
           </a:p>
         </p:txBody>
@@ -10119,7 +10119,7 @@
                 </a:solidFill>
                 <a:latin typeface="Menlo"/>
               </a:rPr>
-              <a:t>WALL-CLOCK</a:t>
+              <a:t>PRODUCTION BRIEFINGS</a:t>
             </a:r>
           </a:p>
         </p:txBody>
@@ -10164,7 +10164,7 @@
                 </a:solidFill>
                 <a:latin typeface="Avenir Next"/>
               </a:rPr>
-              <a:t>local app + remote Hermes</a:t>
+              <a:t>authenticated Convex workspace</a:t>
             </a:r>
           </a:p>
         </p:txBody>
@@ -10297,7 +10297,7 @@
                 </a:solidFill>
                 <a:latin typeface="Avenir Next"/>
               </a:rPr>
-              <a:t>7 → 4 → 3</a:t>
+              <a:t>14 → 8 → 6</a:t>
             </a:r>
           </a:p>
         </p:txBody>
@@ -10342,7 +10342,7 @@
                 </a:solidFill>
                 <a:latin typeface="Menlo"/>
               </a:rPr>
-              <a:t>DISCOVERED · FETCHED · PUBLISHED</a:t>
+              <a:t>DISCOVERED · CONSUMED · PUBLISHED</a:t>
             </a:r>
           </a:p>
         </p:txBody>
@@ -10387,7 +10387,7 @@
                 </a:solidFill>
                 <a:latin typeface="Avenir Next"/>
               </a:rPr>
-              <a:t>progressive-depth research</a:t>
+              <a:t>full sources beyond snippets</a:t>
             </a:r>
           </a:p>
         </p:txBody>
@@ -10520,7 +10520,7 @@
                 </a:solidFill>
                 <a:latin typeface="Avenir Next"/>
               </a:rPr>
-              <a:t>4</a:t>
+              <a:t>8</a:t>
             </a:r>
           </a:p>
         </p:txBody>
@@ -10610,7 +10610,7 @@
                 </a:solidFill>
                 <a:latin typeface="Avenir Next"/>
               </a:rPr>
-              <a:t>nothing silently disappears</a:t>
+              <a:t>judgment remains inspectable</a:t>
             </a:r>
           </a:p>
         </p:txBody>
@@ -10743,7 +10743,7 @@
                 </a:solidFill>
                 <a:latin typeface="Avenir Next"/>
               </a:rPr>
-              <a:t>3 specialists</a:t>
+              <a:t>2 exact clips</a:t>
             </a:r>
           </a:p>
         </p:txBody>
@@ -10788,7 +10788,7 @@
                 </a:solidFill>
                 <a:latin typeface="Menlo"/>
               </a:rPr>
-              <a:t>ONE NATIVE DELEGATION</a:t>
+              <a:t>TIMESTAMP-BOUNDED VIDEODB STREAMS</a:t>
             </a:r>
           </a:p>
         </p:txBody>
@@ -10833,7 +10833,7 @@
                 </a:solidFill>
                 <a:latin typeface="Avenir Next"/>
               </a:rPr>
-              <a:t>two analysts + personal editor</a:t>
+              <a:t>8.72s + 16.66s</a:t>
             </a:r>
           </a:p>
         </p:txBody>
@@ -11011,7 +11011,7 @@
                 </a:solidFill>
                 <a:latin typeface="Menlo"/>
               </a:rPr>
-              <a:t>SOURCE  arxiv.org/html/2605.26252v1</a:t>
+              <a:t>SOURCE  arxiv.org/abs/2605.26252</a:t>
             </a:r>
             <a:br/>
             <a:r>
@@ -11021,7 +11021,7 @@
                 </a:solidFill>
                 <a:latin typeface="Menlo"/>
               </a:rPr>
-              <a:t>LOCATOR Is Agent Memory a Database? · paragraph 12</a:t>
+              <a:t>LOCATOR Is Agent Memory a Database? · paragraph 13</a:t>
             </a:r>
             <a:br/>
             <a:r>
@@ -11031,7 +11031,7 @@
                 </a:solidFill>
                 <a:latin typeface="Menlo"/>
               </a:rPr>
-              <a:t>SHA-256 61475cf3…97fa7564</a:t>
+              <a:t>SHA-256 f8853e7c…1432385b</a:t>
             </a:r>
           </a:p>
         </p:txBody>
@@ -11076,7 +11076,7 @@
                 </a:solidFill>
                 <a:latin typeface="Menlo"/>
               </a:rPr>
-              <a:t>Exact substring check passed before publication.</a:t>
+              <a:t>6 / 6 production claims passed exact evidence validation.</a:t>
             </a:r>
           </a:p>
         </p:txBody>
@@ -11166,7 +11166,7 @@
                 </a:solidFill>
                 <a:latin typeface="Menlo"/>
               </a:rPr>
-              <a:t>WHAT THE RECEIPT PROVES</a:t>
+              <a:t>WHAT THE RECEIPTS PROVE</a:t>
             </a:r>
           </a:p>
         </p:txBody>
@@ -11299,7 +11299,7 @@
                 </a:solidFill>
                 <a:latin typeface="Avenir Next"/>
               </a:rPr>
-              <a:t>Live LinkUp discovery + primary fetch</a:t>
+              <a:t>Public app + identity-owned workspace</a:t>
             </a:r>
           </a:p>
         </p:txBody>
@@ -11432,7 +11432,7 @@
                 </a:solidFill>
                 <a:latin typeface="Avenir Next"/>
               </a:rPr>
-              <a:t>Hermes run + delegation receipt persisted</a:t>
+              <a:t>Live LinkUp discovery + primary fetch</a:t>
             </a:r>
           </a:p>
         </p:txBody>
@@ -11565,7 +11565,7 @@
                 </a:solidFill>
                 <a:latin typeface="Avenir Next"/>
               </a:rPr>
-              <a:t>3 exact-matched findings; snippets excluded</a:t>
+              <a:t>2 Hermes native delegation receipts</a:t>
             </a:r>
           </a:p>
         </p:txBody>
@@ -11698,7 +11698,7 @@
                 </a:solidFill>
                 <a:latin typeface="Avenir Next"/>
               </a:rPr>
-              <a:t>VideoDB exact moment at 0:30–0:44 playable</a:t>
+              <a:t>6 exact-matched findings; snippets excluded</a:t>
             </a:r>
           </a:p>
         </p:txBody>
@@ -11831,7 +11831,7 @@
                 </a:solidFill>
                 <a:latin typeface="Avenir Next"/>
               </a:rPr>
-              <a:t>Feedback approved as visible TasteDoc v2</a:t>
+              <a:t>2 timestamp-bounded VideoDB clips</a:t>
             </a:r>
           </a:p>
         </p:txBody>
@@ -11876,7 +11876,7 @@
                 </a:solidFill>
                 <a:latin typeface="Menlo"/>
               </a:rPr>
-              <a:t>HONESTY BOUNDARY · VideoDB is a separate one-source receipt; no product users, traffic, or model cost claimed</a:t>
+              <a:t>HONESTY BOUNDARY · production receipts are real; external users, traffic, and verified model cost are not claimed</a:t>
             </a:r>
           </a:p>
         </p:txBody>
@@ -12187,7 +12187,7 @@
                 </a:solidFill>
                 <a:latin typeface="Georgia"/>
               </a:rPr>
-              <a:t>Most tools help you consume faster.</a:t>
+              <a:t>The internet will keep getting bigger.</a:t>
             </a:r>
           </a:p>
         </p:txBody>
@@ -12232,7 +12232,7 @@
                 </a:solidFill>
                 <a:latin typeface="Georgia"/>
               </a:rPr>
-              <a:t>Cerno decides what deserves</a:t>
+              <a:t>Your attention will not.</a:t>
             </a:r>
             <a:br/>
             <a:r>
@@ -12242,7 +12242,7 @@
                 </a:solidFill>
                 <a:latin typeface="Georgia"/>
               </a:rPr>
-              <a:t>to be consumed at all.</a:t>
+              <a:t>Cerno decides what deserves it.</a:t>
             </a:r>
           </a:p>
         </p:txBody>
@@ -12651,7 +12651,7 @@
         <p:spPr>
           <a:xfrm>
             <a:off x="676656" y="5074920"/>
-            <a:ext cx="7498079" cy="475488"/>
+            <a:ext cx="8046720" cy="475488"/>
           </a:xfrm>
           <a:prstGeom prst="rect">
             <a:avLst/>
@@ -12682,7 +12682,7 @@
                 </a:solidFill>
                 <a:latin typeface="Georgia"/>
               </a:rPr>
-              <a:t>Consume less. Understand more.</a:t>
+              <a:t>One mission in. One trusted briefing out.</a:t>
             </a:r>
           </a:p>
         </p:txBody>

</xml_diff>

<commit_message>
Restore judgment layer presentation headline
</commit_message>
<xml_diff>
--- a/presentation/output/Cerno-Hackathon-Presentation.pptx
+++ b/presentation/output/Cerno-Hackathon-Presentation.pptx
@@ -3331,23 +3331,23 @@
               </a:spcAft>
             </a:pPr>
             <a:r>
-              <a:rPr sz="3600" b="1" i="0">
+              <a:rPr sz="3300" b="1" i="0">
                 <a:solidFill>
                   <a:srgbClr val="FFFFFF"/>
                 </a:solidFill>
                 <a:latin typeface="Georgia"/>
               </a:rPr>
-              <a:t>Your personal research desk.</a:t>
+              <a:t>The judgment layer between</a:t>
             </a:r>
             <a:br/>
             <a:r>
-              <a:rPr sz="3600" b="1" i="0">
+              <a:rPr sz="3300" b="1" i="0">
                 <a:solidFill>
                   <a:srgbClr val="FFFFFF"/>
                 </a:solidFill>
                 <a:latin typeface="Georgia"/>
               </a:rPr>
-              <a:t>Staffed by agents.</a:t>
+              <a:t>the internet and your attention.</a:t>
             </a:r>
           </a:p>
         </p:txBody>
@@ -3392,7 +3392,7 @@
                 </a:solidFill>
                 <a:latin typeface="Avenir Next"/>
               </a:rPr>
-              <a:t>One mission in. One finite, cited briefing out.</a:t>
+              <a:t>A personal research-and-briefing desk, run by agents.</a:t>
             </a:r>
           </a:p>
         </p:txBody>

</xml_diff>